<commit_message>
Polish demo walkthrough deck and add PDF export
Crop Telegram screenshots to the relevant messages, add alert
history to the impact slide, fix label and title wrapping, and
link the live deck and walkthrough from the README.

Co-Authored-By: Claude Opus 5.5 <noreply@anthropic.com>
</commit_message>
<xml_diff>
--- a/pitch/HoldOn-demo-walkthrough.pptx
+++ b/pitch/HoldOn-demo-walkthrough.pptx
@@ -116,13 +116,13 @@
   <p:extLst>
     <p:ext uri="{521415D9-36F7-43E2-AB2F-B90AF26B5E84}">
       <p14:sectionLst xmlns:p14="http://schemas.microsoft.com/office/powerpoint/2010/main">
-        <p14:section name="Intro" id="{c9a9b9d1-0c19-4f55-bc3e-0842a53ec02c}">
+        <p14:section name="Intro" id="{d0cd1817-9dd2-1b3b-8aaa-79f2c2b74588}">
           <p14:sldIdLst>
             <p14:sldId id="256"/>
             <p14:sldId id="257"/>
           </p14:sldIdLst>
         </p14:section>
-        <p14:section name="Demo steps" id="{2ca2ab73-b7a1-1e57-907a-bec66e9af04f}">
+        <p14:section name="Demo steps" id="{5c18514f-4f4c-38d4-9167-5ae18eb7a148}">
           <p14:sldIdLst>
             <p14:sldId id="258"/>
             <p14:sldId id="259"/>
@@ -133,7 +133,7 @@
             <p14:sldId id="264"/>
           </p14:sldIdLst>
         </p14:section>
-        <p14:section name="Recap" id="{799e2d54-911f-ff89-71a2-a6f91ce61e4a}">
+        <p14:section name="Recap" id="{16edfe5c-e6d8-530a-cfc9-1be459660cb2}">
           <p14:sldIdLst>
             <p14:sldId id="265"/>
           </p14:sldIdLst>
@@ -2079,8 +2079,11 @@
                   <a:schemeClr val="bg2"/>
                 </a:solidFill>
               </a:rPr>
-              <a:t>How HoldOn stops a tech-support scam, step by step. </a:t>
-            </a:r>
+              <a:t>How HoldOn stops a tech-support scam, step by step.</a:t>
+            </a:r>
+            <a:endParaRPr lang="en-US" sz="1800" dirty="0"/>
+          </a:p>
+          <a:p>
             <a:pPr indent="0" marL="0">
               <a:buNone/>
             </a:pPr>
@@ -2216,7 +2219,21 @@
                   <a:schemeClr val="bg1"/>
                 </a:solidFill>
               </a:rPr>
-              <a:t>She can't call for help. HoldOn does.</a:t>
+              <a:t>She can't call for help.</a:t>
+            </a:r>
+            <a:endParaRPr lang="en-US" sz="4000" dirty="0"/>
+          </a:p>
+          <a:p>
+            <a:pPr algn="l" indent="0" marL="0">
+              <a:buNone/>
+            </a:pPr>
+            <a:r>
+              <a:rPr lang="en-US" sz="4000" b="1" dirty="0">
+                <a:solidFill>
+                  <a:schemeClr val="accent1"/>
+                </a:solidFill>
+              </a:rPr>
+              <a:t>HoldOn does.</a:t>
             </a:r>
             <a:endParaRPr lang="en-US" sz="4000" dirty="0"/>
           </a:p>
@@ -3760,7 +3777,7 @@
           <a:bodyPr wrap="square" lIns="0" tIns="0" rIns="0" bIns="0" rtlCol="0" anchor="t"/>
           <a:lstStyle/>
           <a:p>
-            <a:pPr marL="342900" indent="-342900">
+            <a:pPr marL="190500" indent="-190500">
               <a:spcAft>
                 <a:spcPts val="800"/>
               </a:spcAft>
@@ -3778,7 +3795,7 @@
             <a:endParaRPr lang="en-US" sz="1400" dirty="0"/>
           </a:p>
           <a:p>
-            <a:pPr marL="342900" indent="-342900">
+            <a:pPr marL="190500" indent="-190500">
               <a:spcAft>
                 <a:spcPts val="800"/>
               </a:spcAft>
@@ -3796,7 +3813,7 @@
             <a:endParaRPr lang="en-US" sz="1400" dirty="0"/>
           </a:p>
           <a:p>
-            <a:pPr marL="342900" indent="-342900">
+            <a:pPr marL="190500" indent="-190500">
               <a:spcAft>
                 <a:spcPts val="800"/>
               </a:spcAft>
@@ -3886,12 +3903,12 @@
         </p:nvSpPr>
         <p:spPr>
           <a:xfrm>
-            <a:off x="3877056" y="2007220"/>
-            <a:ext cx="2350008" cy="1746280"/>
+            <a:off x="4533375" y="1133856"/>
+            <a:ext cx="3551970" cy="2624328"/>
           </a:xfrm>
           <a:prstGeom prst="roundRect">
             <a:avLst>
-              <a:gd name="adj" fmla="val 4189"/>
+              <a:gd name="adj" fmla="val 2787"/>
             </a:avLst>
           </a:prstGeom>
           <a:solidFill>
@@ -3921,8 +3938,8 @@
         </p:blipFill>
         <p:spPr>
           <a:xfrm>
-            <a:off x="3931920" y="2062084"/>
-            <a:ext cx="2240280" cy="1636552"/>
+            <a:off x="4588239" y="1188720"/>
+            <a:ext cx="3442242" cy="2514600"/>
           </a:xfrm>
           <a:prstGeom prst="rect">
             <a:avLst/>
@@ -3937,12 +3954,12 @@
         </p:nvSpPr>
         <p:spPr>
           <a:xfrm>
-            <a:off x="6300216" y="2373252"/>
-            <a:ext cx="2441448" cy="1014215"/>
+            <a:off x="3907536" y="3877056"/>
+            <a:ext cx="4803648" cy="749808"/>
           </a:xfrm>
           <a:prstGeom prst="roundRect">
             <a:avLst>
-              <a:gd name="adj" fmla="val 7213"/>
+              <a:gd name="adj" fmla="val 9756"/>
             </a:avLst>
           </a:prstGeom>
           <a:solidFill>
@@ -3972,8 +3989,8 @@
         </p:blipFill>
         <p:spPr>
           <a:xfrm>
-            <a:off x="6355080" y="2428116"/>
-            <a:ext cx="2331720" cy="904487"/>
+            <a:off x="3962400" y="3931920"/>
+            <a:ext cx="4693920" cy="640080"/>
           </a:xfrm>
           <a:prstGeom prst="rect">
             <a:avLst/>
@@ -4206,7 +4223,7 @@
           <a:bodyPr wrap="square" lIns="0" tIns="0" rIns="0" bIns="0" rtlCol="0" anchor="t"/>
           <a:lstStyle/>
           <a:p>
-            <a:pPr marL="342900" indent="-342900">
+            <a:pPr marL="190500" indent="-190500">
               <a:spcAft>
                 <a:spcPts val="800"/>
               </a:spcAft>
@@ -4224,7 +4241,7 @@
             <a:endParaRPr lang="en-US" sz="1400" dirty="0"/>
           </a:p>
           <a:p>
-            <a:pPr marL="342900" indent="-342900">
+            <a:pPr marL="190500" indent="-190500">
               <a:spcAft>
                 <a:spcPts val="800"/>
               </a:spcAft>
@@ -4242,7 +4259,7 @@
             <a:endParaRPr lang="en-US" sz="1400" dirty="0"/>
           </a:p>
           <a:p>
-            <a:pPr marL="342900" indent="-342900">
+            <a:pPr marL="190500" indent="-190500">
               <a:spcAft>
                 <a:spcPts val="800"/>
               </a:spcAft>
@@ -4601,7 +4618,7 @@
           <a:bodyPr wrap="square" lIns="0" tIns="0" rIns="0" bIns="0" rtlCol="0" anchor="t"/>
           <a:lstStyle/>
           <a:p>
-            <a:pPr marL="342900" indent="-342900">
+            <a:pPr marL="190500" indent="-190500">
               <a:spcAft>
                 <a:spcPts val="800"/>
               </a:spcAft>
@@ -4619,7 +4636,7 @@
             <a:endParaRPr lang="en-US" sz="1400" dirty="0"/>
           </a:p>
           <a:p>
-            <a:pPr marL="342900" indent="-342900">
+            <a:pPr marL="190500" indent="-190500">
               <a:spcAft>
                 <a:spcPts val="800"/>
               </a:spcAft>
@@ -4637,7 +4654,7 @@
             <a:endParaRPr lang="en-US" sz="1400" dirty="0"/>
           </a:p>
           <a:p>
-            <a:pPr marL="342900" indent="-342900">
+            <a:pPr marL="190500" indent="-190500">
               <a:spcAft>
                 <a:spcPts val="800"/>
               </a:spcAft>
@@ -4996,7 +5013,7 @@
           <a:bodyPr wrap="square" lIns="0" tIns="0" rIns="0" bIns="0" rtlCol="0" anchor="t"/>
           <a:lstStyle/>
           <a:p>
-            <a:pPr marL="342900" indent="-342900">
+            <a:pPr marL="190500" indent="-190500">
               <a:spcAft>
                 <a:spcPts val="800"/>
               </a:spcAft>
@@ -5014,7 +5031,7 @@
             <a:endParaRPr lang="en-US" sz="1400" dirty="0"/>
           </a:p>
           <a:p>
-            <a:pPr marL="342900" indent="-342900">
+            <a:pPr marL="190500" indent="-190500">
               <a:spcAft>
                 <a:spcPts val="800"/>
               </a:spcAft>
@@ -5032,7 +5049,7 @@
             <a:endParaRPr lang="en-US" sz="1400" dirty="0"/>
           </a:p>
           <a:p>
-            <a:pPr marL="342900" indent="-342900">
+            <a:pPr marL="190500" indent="-190500">
               <a:spcAft>
                 <a:spcPts val="800"/>
               </a:spcAft>
@@ -5122,12 +5139,12 @@
         </p:nvSpPr>
         <p:spPr>
           <a:xfrm>
-            <a:off x="3877056" y="1935021"/>
-            <a:ext cx="4864608" cy="1890678"/>
+            <a:off x="3877056" y="2012800"/>
+            <a:ext cx="4864608" cy="1735121"/>
           </a:xfrm>
           <a:prstGeom prst="roundRect">
             <a:avLst>
-              <a:gd name="adj" fmla="val 3869"/>
+              <a:gd name="adj" fmla="val 4216"/>
             </a:avLst>
           </a:prstGeom>
           <a:solidFill>
@@ -5157,8 +5174,8 @@
         </p:blipFill>
         <p:spPr>
           <a:xfrm>
-            <a:off x="3931920" y="1989885"/>
-            <a:ext cx="4754880" cy="1780950"/>
+            <a:off x="3931920" y="2067664"/>
+            <a:ext cx="4754880" cy="1625393"/>
           </a:xfrm>
           <a:prstGeom prst="rect">
             <a:avLst/>
@@ -5391,7 +5408,7 @@
           <a:bodyPr wrap="square" lIns="0" tIns="0" rIns="0" bIns="0" rtlCol="0" anchor="t"/>
           <a:lstStyle/>
           <a:p>
-            <a:pPr marL="342900" indent="-342900">
+            <a:pPr marL="190500" indent="-190500">
               <a:spcAft>
                 <a:spcPts val="800"/>
               </a:spcAft>
@@ -5409,7 +5426,7 @@
             <a:endParaRPr lang="en-US" sz="1400" dirty="0"/>
           </a:p>
           <a:p>
-            <a:pPr marL="342900" indent="-342900">
+            <a:pPr marL="190500" indent="-190500">
               <a:spcAft>
                 <a:spcPts val="800"/>
               </a:spcAft>
@@ -5427,7 +5444,7 @@
             <a:endParaRPr lang="en-US" sz="1400" dirty="0"/>
           </a:p>
           <a:p>
-            <a:pPr marL="342900" indent="-342900">
+            <a:pPr marL="190500" indent="-190500">
               <a:spcAft>
                 <a:spcPts val="800"/>
               </a:spcAft>
@@ -5517,12 +5534,12 @@
         </p:nvSpPr>
         <p:spPr>
           <a:xfrm>
-            <a:off x="3963924" y="1133856"/>
-            <a:ext cx="4690872" cy="3493008"/>
+            <a:off x="3877056" y="2324229"/>
+            <a:ext cx="4864608" cy="1112263"/>
           </a:xfrm>
           <a:prstGeom prst="roundRect">
             <a:avLst>
-              <a:gd name="adj" fmla="val 2094"/>
+              <a:gd name="adj" fmla="val 6577"/>
             </a:avLst>
           </a:prstGeom>
           <a:solidFill>
@@ -5552,8 +5569,8 @@
         </p:blipFill>
         <p:spPr>
           <a:xfrm>
-            <a:off x="4018788" y="1188720"/>
-            <a:ext cx="4581144" cy="3383280"/>
+            <a:off x="3931920" y="2379093"/>
+            <a:ext cx="4754880" cy="1002535"/>
           </a:xfrm>
           <a:prstGeom prst="rect">
             <a:avLst/>
@@ -5731,14 +5748,14 @@
       </p:sp>
       <p:sp>
         <p:nvSpPr>
-          <p:cNvPr id="5" name="Who"/>
+          <p:cNvPr id="5" name="Telegram label"/>
           <p:cNvSpPr txBox="1"/>
           <p:nvPr/>
         </p:nvSpPr>
         <p:spPr>
           <a:xfrm>
             <a:off x="457200" y="1234440"/>
-            <a:ext cx="3108960" cy="320040"/>
+            <a:ext cx="3291840" cy="274320"/>
           </a:xfrm>
           <a:prstGeom prst="rect">
             <a:avLst/>
@@ -5754,107 +5771,31 @@
               <a:buNone/>
             </a:pPr>
             <a:r>
-              <a:rPr lang="en-US" sz="1200" b="1" spc="200" kern="0" dirty="0">
+              <a:rPr lang="en-US" sz="1100" b="1" spc="200" kern="0" dirty="0">
                 <a:solidFill>
                   <a:schemeClr val="accent3"/>
                 </a:solidFill>
               </a:rPr>
-              <a:t>SARAH'S DASHBOARD</a:t>
-            </a:r>
-            <a:endParaRPr lang="en-US" sz="1200" dirty="0"/>
-          </a:p>
-        </p:txBody>
-      </p:sp>
-      <p:sp>
-        <p:nvSpPr>
-          <p:cNvPr id="6" name="What happens"/>
-          <p:cNvSpPr txBox="1"/>
-          <p:nvPr/>
-        </p:nvSpPr>
-        <p:spPr>
-          <a:xfrm>
-            <a:off x="457200" y="1645920"/>
-            <a:ext cx="3108960" cy="1920240"/>
-          </a:xfrm>
-          <a:prstGeom prst="rect">
-            <a:avLst/>
-          </a:prstGeom>
-          <a:noFill/>
-          <a:ln/>
-        </p:spPr>
-        <p:txBody>
-          <a:bodyPr wrap="square" lIns="0" tIns="0" rIns="0" bIns="0" rtlCol="0" anchor="t"/>
-          <a:lstStyle/>
-          <a:p>
-            <a:pPr marL="342900" indent="-342900">
-              <a:spcAft>
-                <a:spcPts val="800"/>
-              </a:spcAft>
-              <a:buSzPct val="100000"/>
-              <a:buChar char="•"/>
-            </a:pPr>
-            <a:r>
-              <a:rPr lang="en-US" sz="1400" dirty="0">
-                <a:solidFill>
-                  <a:schemeClr val="bg1"/>
-                </a:solidFill>
-              </a:rPr>
-              <a:t>Alerts, scams stopped, false alarms</a:t>
-            </a:r>
-            <a:endParaRPr lang="en-US" sz="1400" dirty="0"/>
-          </a:p>
-          <a:p>
-            <a:pPr marL="342900" indent="-342900">
-              <a:spcAft>
-                <a:spcPts val="800"/>
-              </a:spcAft>
-              <a:buSzPct val="100000"/>
-              <a:buChar char="•"/>
-            </a:pPr>
-            <a:r>
-              <a:rPr lang="en-US" sz="1400" dirty="0">
-                <a:solidFill>
-                  <a:schemeClr val="bg1"/>
-                </a:solidFill>
-              </a:rPr>
-              <a:t>Precision: answered alerts that were real scams</a:t>
-            </a:r>
-            <a:endParaRPr lang="en-US" sz="1400" dirty="0"/>
-          </a:p>
-          <a:p>
-            <a:pPr marL="342900" indent="-342900">
-              <a:spcAft>
-                <a:spcPts val="800"/>
-              </a:spcAft>
-              <a:buSzPct val="100000"/>
-              <a:buChar char="•"/>
-            </a:pPr>
-            <a:r>
-              <a:rPr lang="en-US" sz="1400" dirty="0">
-                <a:solidFill>
-                  <a:schemeClr val="bg1"/>
-                </a:solidFill>
-              </a:rPr>
-              <a:t>Live counts from our test runs today</a:t>
-            </a:r>
-            <a:endParaRPr lang="en-US" sz="1400" dirty="0"/>
-          </a:p>
-        </p:txBody>
-      </p:sp>
-      <p:sp>
-        <p:nvSpPr>
-          <p:cNvPr id="7" name="Dashboard stats frame"/>
+              <a:t>ANSWERED IN TELEGRAM</a:t>
+            </a:r>
+            <a:endParaRPr lang="en-US" sz="1100" dirty="0"/>
+          </a:p>
+        </p:txBody>
+      </p:sp>
+      <p:sp>
+        <p:nvSpPr>
+          <p:cNvPr id="6" name="Telegram alert history with logged outcomes frame"/>
           <p:cNvSpPr/>
           <p:nvPr/>
         </p:nvSpPr>
         <p:spPr>
           <a:xfrm>
-            <a:off x="3877056" y="1700784"/>
-            <a:ext cx="4864608" cy="1536192"/>
+            <a:off x="450914" y="1545336"/>
+            <a:ext cx="3304413" cy="3081528"/>
           </a:xfrm>
           <a:prstGeom prst="roundRect">
             <a:avLst>
-              <a:gd name="adj" fmla="val 4762"/>
+              <a:gd name="adj" fmla="val 2374"/>
             </a:avLst>
           </a:prstGeom>
           <a:solidFill>
@@ -5870,7 +5811,7 @@
       </p:sp>
       <p:pic>
         <p:nvPicPr>
-          <p:cNvPr id="8" name="Dashboard stats" descr="Dashboard stats">    </p:cNvPr>
+          <p:cNvPr id="7" name="Telegram alert history with logged outcomes" descr="Telegram alert history with logged outcomes">    </p:cNvPr>
           <p:cNvPicPr>
             <a:picLocks noChangeAspect="1"/>
           </p:cNvPicPr>
@@ -5884,8 +5825,8 @@
         </p:blipFill>
         <p:spPr>
           <a:xfrm>
-            <a:off x="3931920" y="1755648"/>
-            <a:ext cx="4754880" cy="1426464"/>
+            <a:off x="505778" y="1600200"/>
+            <a:ext cx="3194685" cy="2971800"/>
           </a:xfrm>
           <a:prstGeom prst="rect">
             <a:avLst/>
@@ -5894,14 +5835,14 @@
       </p:pic>
       <p:sp>
         <p:nvSpPr>
-          <p:cNvPr id="9" name="Dashboard caption"/>
+          <p:cNvPr id="8" name="Dashboard label"/>
           <p:cNvSpPr txBox="1"/>
           <p:nvPr/>
         </p:nvSpPr>
         <p:spPr>
           <a:xfrm>
-            <a:off x="3931920" y="3749040"/>
-            <a:ext cx="4754880" cy="548640"/>
+            <a:off x="4114800" y="1234440"/>
+            <a:ext cx="4572000" cy="274320"/>
           </a:xfrm>
           <a:prstGeom prst="rect">
             <a:avLst/>
@@ -5917,14 +5858,120 @@
               <a:buNone/>
             </a:pPr>
             <a:r>
-              <a:rPr lang="en-US" sz="1200" i="1" dirty="0">
-                <a:solidFill>
-                  <a:schemeClr val="bg2"/>
-                </a:solidFill>
-              </a:rPr>
-              <a:t>False alarms are expected in testing: we triggered alerts on purpose to tune detection.</a:t>
-            </a:r>
-            <a:endParaRPr lang="en-US" sz="1200" dirty="0"/>
+              <a:rPr lang="en-US" sz="1100" b="1" spc="200" kern="0" dirty="0">
+                <a:solidFill>
+                  <a:schemeClr val="accent3"/>
+                </a:solidFill>
+              </a:rPr>
+              <a:t>ROLLED UP ON SARAH'S DASHBOARD</a:t>
+            </a:r>
+            <a:endParaRPr lang="en-US" sz="1100" dirty="0"/>
+          </a:p>
+        </p:txBody>
+      </p:sp>
+      <p:sp>
+        <p:nvSpPr>
+          <p:cNvPr id="9" name="Dashboard stats frame"/>
+          <p:cNvSpPr/>
+          <p:nvPr/>
+        </p:nvSpPr>
+        <p:spPr>
+          <a:xfrm>
+            <a:off x="4059936" y="1545336"/>
+            <a:ext cx="4681728" cy="1481328"/>
+          </a:xfrm>
+          <a:prstGeom prst="roundRect">
+            <a:avLst>
+              <a:gd name="adj" fmla="val 4938"/>
+            </a:avLst>
+          </a:prstGeom>
+          <a:solidFill>
+            <a:schemeClr val="tx2"/>
+          </a:solidFill>
+          <a:ln w="12700">
+            <a:solidFill>
+              <a:schemeClr val="accent4"/>
+            </a:solidFill>
+            <a:prstDash val="solid"/>
+          </a:ln>
+        </p:spPr>
+      </p:sp>
+      <p:pic>
+        <p:nvPicPr>
+          <p:cNvPr id="10" name="Dashboard stats" descr="Dashboard stats">    </p:cNvPr>
+          <p:cNvPicPr>
+            <a:picLocks noChangeAspect="1"/>
+          </p:cNvPicPr>
+          <p:nvPr/>
+        </p:nvPicPr>
+        <p:blipFill>
+          <a:blip r:embed="rId2"/>
+          <a:stretch>
+            <a:fillRect/>
+          </a:stretch>
+        </p:blipFill>
+        <p:spPr>
+          <a:xfrm>
+            <a:off x="4114800" y="1600200"/>
+            <a:ext cx="4572000" cy="1371600"/>
+          </a:xfrm>
+          <a:prstGeom prst="rect">
+            <a:avLst/>
+          </a:prstGeom>
+        </p:spPr>
+      </p:pic>
+      <p:sp>
+        <p:nvSpPr>
+          <p:cNvPr id="11" name="Dashboard notes"/>
+          <p:cNvSpPr txBox="1"/>
+          <p:nvPr/>
+        </p:nvSpPr>
+        <p:spPr>
+          <a:xfrm>
+            <a:off x="4114800" y="3200400"/>
+            <a:ext cx="4572000" cy="1280160"/>
+          </a:xfrm>
+          <a:prstGeom prst="rect">
+            <a:avLst/>
+          </a:prstGeom>
+          <a:noFill/>
+          <a:ln/>
+        </p:spPr>
+        <p:txBody>
+          <a:bodyPr wrap="square" lIns="0" tIns="0" rIns="0" bIns="0" rtlCol="0" anchor="t"/>
+          <a:lstStyle/>
+          <a:p>
+            <a:pPr marL="190500" indent="-190500">
+              <a:spcAft>
+                <a:spcPts val="600"/>
+              </a:spcAft>
+              <a:buSzPct val="100000"/>
+              <a:buChar char="•"/>
+            </a:pPr>
+            <a:r>
+              <a:rPr lang="en-US" sz="1400" dirty="0">
+                <a:solidFill>
+                  <a:schemeClr val="bg1"/>
+                </a:solidFill>
+              </a:rPr>
+              <a:t>Scams stopped, false alarms and precision, counted live</a:t>
+            </a:r>
+            <a:endParaRPr lang="en-US" sz="1400" dirty="0"/>
+          </a:p>
+          <a:p>
+            <a:pPr marL="190500" indent="-190500">
+              <a:buSzPct val="100000"/>
+              <a:buChar char="•"/>
+            </a:pPr>
+            <a:r>
+              <a:rPr lang="en-US" sz="1400" dirty="0">
+                <a:solidFill>
+                  <a:schemeClr val="bg1"/>
+                </a:solidFill>
+              </a:rPr>
+              <a:t>Real counts from our test runs today: false alarms were triggered on purpose to tune detection</a:t>
+            </a:r>
+            <a:endParaRPr lang="en-US" sz="1400" dirty="0"/>
           </a:p>
         </p:txBody>
       </p:sp>
@@ -6154,7 +6201,7 @@
           <a:bodyPr wrap="square" lIns="0" tIns="0" rIns="0" bIns="0" rtlCol="0" anchor="t"/>
           <a:lstStyle/>
           <a:p>
-            <a:pPr marL="342900" indent="-342900">
+            <a:pPr marL="190500" indent="-190500">
               <a:spcAft>
                 <a:spcPts val="800"/>
               </a:spcAft>
@@ -6172,7 +6219,7 @@
             <a:endParaRPr lang="en-US" sz="1400" dirty="0"/>
           </a:p>
           <a:p>
-            <a:pPr marL="342900" indent="-342900">
+            <a:pPr marL="190500" indent="-190500">
               <a:spcAft>
                 <a:spcPts val="800"/>
               </a:spcAft>
@@ -6190,7 +6237,7 @@
             <a:endParaRPr lang="en-US" sz="1400" dirty="0"/>
           </a:p>
           <a:p>
-            <a:pPr marL="342900" indent="-342900">
+            <a:pPr marL="190500" indent="-190500">
               <a:spcAft>
                 <a:spcPts val="800"/>
               </a:spcAft>

</xml_diff>

<commit_message>
Rewrite demo walkthrough in plain language
Replace jargon (extension, remote access, tamper, precision) with
simple wording a non-technical reader can follow.

Co-Authored-By: Claude Opus 5.5 <noreply@anthropic.com>
</commit_message>
<xml_diff>
--- a/pitch/HoldOn-demo-walkthrough.pptx
+++ b/pitch/HoldOn-demo-walkthrough.pptx
@@ -116,13 +116,13 @@
   <p:extLst>
     <p:ext uri="{521415D9-36F7-43E2-AB2F-B90AF26B5E84}">
       <p14:sectionLst xmlns:p14="http://schemas.microsoft.com/office/powerpoint/2010/main">
-        <p14:section name="Intro" id="{d0cd1817-9dd2-1b3b-8aaa-79f2c2b74588}">
+        <p14:section name="Intro" id="{71b5d902-9e5c-c664-2b68-faf312e24df2}">
           <p14:sldIdLst>
             <p14:sldId id="256"/>
             <p14:sldId id="257"/>
           </p14:sldIdLst>
         </p14:section>
-        <p14:section name="Demo steps" id="{5c18514f-4f4c-38d4-9167-5ae18eb7a148}">
+        <p14:section name="Demo steps" id="{86d58b6f-09c1-c57c-5491-83b89dfcb10f}">
           <p14:sldIdLst>
             <p14:sldId id="258"/>
             <p14:sldId id="259"/>
@@ -133,7 +133,7 @@
             <p14:sldId id="264"/>
           </p14:sldIdLst>
         </p14:section>
-        <p14:section name="Recap" id="{16edfe5c-e6d8-530a-cfc9-1be459660cb2}">
+        <p14:section name="Recap" id="{588bd603-78f3-c850-b114-c981e77a7054}">
           <p14:sldIdLst>
             <p14:sldId id="265"/>
           </p14:sldIdLst>
@@ -2041,7 +2041,7 @@
                   <a:schemeClr val="bg1"/>
                 </a:solidFill>
               </a:rPr>
-              <a:t>HoldOn: demo walkthrough</a:t>
+              <a:t>HoldOn: how it works</a:t>
             </a:r>
             <a:endParaRPr lang="en-US" sz="4000" dirty="0"/>
           </a:p>
@@ -2079,7 +2079,7 @@
                   <a:schemeClr val="bg2"/>
                 </a:solidFill>
               </a:rPr>
-              <a:t>How HoldOn stops a tech-support scam, step by step.</a:t>
+              <a:t>How HoldOn stops a computer scam, step by step.</a:t>
             </a:r>
             <a:endParaRPr lang="en-US" sz="1800" dirty="0"/>
           </a:p>
@@ -2271,7 +2271,7 @@
                   <a:schemeClr val="bg2"/>
                 </a:solidFill>
               </a:rPr>
-              <a:t>Spots the scam moment → Mom sees STOP → Sarah's phone buzzes → Sarah calls → Scam stopped</a:t>
+              <a:t>HoldOn spots the trick → Mom sees STOP → Sarah's phone buzzes → Sarah calls → Scam stopped</a:t>
             </a:r>
             <a:endParaRPr lang="en-US" sz="1800" dirty="0"/>
           </a:p>
@@ -2307,7 +2307,7 @@
                   <a:schemeClr val="bg2"/>
                 </a:solidFill>
               </a:rPr>
-              <a:t>Built in one afternoon: Chrome extension · Next.js · Claude via RouterPlus · Telegram Bot API</a:t>
+              <a:t>Built in one afternoon with a browser add-on, a small server, AI (Claude) and Telegram</a:t>
             </a:r>
             <a:endParaRPr lang="en-US" sz="1300" dirty="0"/>
           </a:p>
@@ -2370,7 +2370,7 @@
                   <a:schemeClr val="bg1"/>
                 </a:solidFill>
               </a:rPr>
-              <a:t>The setup</a:t>
+              <a:t>Who's who</a:t>
             </a:r>
             <a:endParaRPr lang="en-US" sz="2800" dirty="0"/>
           </a:p>
@@ -2530,7 +2530,7 @@
                   <a:schemeClr val="bg1"/>
                 </a:solidFill>
               </a:rPr>
-              <a:t>Mom's laptop: Chrome with the HoldOn extension</a:t>
+              <a:t>Mom. HoldOn is added to her laptop's web browser.</a:t>
             </a:r>
             <a:endParaRPr lang="en-US" sz="1300" dirty="0"/>
           </a:p>
@@ -2629,7 +2629,7 @@
                   <a:schemeClr val="bg1"/>
                 </a:solidFill>
               </a:rPr>
-              <a:t>Her daughter, far away: gets alerts on Telegram</a:t>
+              <a:t>Her daughter. Lives far away. Gets alerts on her phone.</a:t>
             </a:r>
             <a:endParaRPr lang="en-US" sz="1300" dirty="0"/>
           </a:p>
@@ -2728,7 +2728,7 @@
                   <a:schemeClr val="bg1"/>
                 </a:solidFill>
               </a:rPr>
-              <a:t>Fake "Microsoft technician" who wants remote access</a:t>
+              <a:t>Pretends to be from Microsoft. Wants to control Mom's computer.</a:t>
             </a:r>
             <a:endParaRPr lang="en-US" sz="1300" dirty="0"/>
           </a:p>
@@ -2825,7 +2825,7 @@
                   <a:schemeClr val="bg1"/>
                 </a:solidFill>
               </a:rPr>
-              <a:t>Setup</a:t>
+              <a:t>Set up</a:t>
             </a:r>
             <a:endParaRPr lang="en-US" sz="1200" dirty="0"/>
           </a:p>
@@ -2945,7 +2945,7 @@
                   <a:schemeClr val="bg1"/>
                 </a:solidFill>
               </a:rPr>
-              <a:t>Fake popup</a:t>
+              <a:t>Fake warning</a:t>
             </a:r>
             <a:endParaRPr lang="en-US" sz="1200" dirty="0"/>
           </a:p>
@@ -3065,7 +3065,7 @@
                   <a:schemeClr val="bg1"/>
                 </a:solidFill>
               </a:rPr>
-              <a:t>AnyDesk</a:t>
+              <a:t>Scam app</a:t>
             </a:r>
             <a:endParaRPr lang="en-US" sz="1200" dirty="0"/>
           </a:p>
@@ -3425,7 +3425,7 @@
                   <a:schemeClr val="bg1"/>
                 </a:solidFill>
               </a:rPr>
-              <a:t>Dashboard</a:t>
+              <a:t>Scoreboard</a:t>
             </a:r>
             <a:endParaRPr lang="en-US" sz="1200" dirty="0"/>
           </a:p>
@@ -3545,7 +3545,7 @@
                   <a:schemeClr val="bg1"/>
                 </a:solidFill>
               </a:rPr>
-              <a:t>Tamper</a:t>
+              <a:t>Can't hide</a:t>
             </a:r>
             <a:endParaRPr lang="en-US" sz="1200" dirty="0"/>
           </a:p>
@@ -3714,7 +3714,7 @@
                   <a:schemeClr val="bg1"/>
                 </a:solidFill>
               </a:rPr>
-              <a:t>Sarah sets up HoldOn for Mom</a:t>
+              <a:t>Sarah turns on HoldOn for Mom</a:t>
             </a:r>
             <a:endParaRPr lang="en-US" sz="2800" dirty="0"/>
           </a:p>
@@ -3750,7 +3750,7 @@
                   <a:schemeClr val="accent3"/>
                 </a:solidFill>
               </a:rPr>
-              <a:t>SARAH · 2 MINUTES</a:t>
+              <a:t>TAKES 2 MINUTES</a:t>
             </a:r>
             <a:endParaRPr lang="en-US" sz="1200" dirty="0"/>
           </a:p>
@@ -3790,7 +3790,7 @@
                   <a:schemeClr val="bg1"/>
                 </a:solidFill>
               </a:rPr>
-              <a:t>Adds HoldOn to Mom's Chrome</a:t>
+              <a:t>Adds HoldOn to Mom's web browser</a:t>
             </a:r>
             <a:endParaRPr lang="en-US" sz="1400" dirty="0"/>
           </a:p>
@@ -3808,7 +3808,7 @@
                   <a:schemeClr val="bg1"/>
                 </a:solidFill>
               </a:rPr>
-              <a:t>Enters names, sees "Connected to Telegram"</a:t>
+              <a:t>Types in both their names</a:t>
             </a:r>
             <a:endParaRPr lang="en-US" sz="1400" dirty="0"/>
           </a:p>
@@ -3826,7 +3826,7 @@
                   <a:schemeClr val="bg1"/>
                 </a:solidFill>
               </a:rPr>
-              <a:t>Clicks Send test alert</a:t>
+              <a:t>Sends a test message to her own phone</a:t>
             </a:r>
             <a:endParaRPr lang="en-US" sz="1400" dirty="0"/>
           </a:p>
@@ -3889,7 +3889,7 @@
                   <a:schemeClr val="accent1"/>
                 </a:solidFill>
               </a:rPr>
-              <a:t>Phone: "HoldOn is now protecting Margaret."</a:t>
+              <a:t>Her phone says: "HoldOn is now protecting Margaret."</a:t>
             </a:r>
             <a:endParaRPr lang="en-US" sz="1400" dirty="0"/>
           </a:p>
@@ -4160,7 +4160,7 @@
                   <a:schemeClr val="bg1"/>
                 </a:solidFill>
               </a:rPr>
-              <a:t>A fake virus warning appears</a:t>
+              <a:t>A fake virus warning pops up</a:t>
             </a:r>
             <a:endParaRPr lang="en-US" sz="2800" dirty="0"/>
           </a:p>
@@ -4196,7 +4196,7 @@
                   <a:schemeClr val="accent3"/>
                 </a:solidFill>
               </a:rPr>
-              <a:t>MARGARET'S SCREEN</a:t>
+              <a:t>ON MOM'S SCREEN</a:t>
             </a:r>
             <a:endParaRPr lang="en-US" sz="1200" dirty="0"/>
           </a:p>
@@ -4236,7 +4236,7 @@
                   <a:schemeClr val="bg1"/>
                 </a:solidFill>
               </a:rPr>
-              <a:t>Scam page: "Your PC is infected. Call Microsoft."</a:t>
+              <a:t>A scary page says her computer has a virus and to call "Microsoft"</a:t>
             </a:r>
             <a:endParaRPr lang="en-US" sz="1400" dirty="0"/>
           </a:p>
@@ -4254,7 +4254,7 @@
                   <a:schemeClr val="bg1"/>
                 </a:solidFill>
               </a:rPr>
-              <a:t>HoldOn spots scam phrases + a toll-free number</a:t>
+              <a:t>HoldOn knows this trick and spots the fake</a:t>
             </a:r>
             <a:endParaRPr lang="en-US" sz="1400" dirty="0"/>
           </a:p>
@@ -4272,7 +4272,7 @@
                   <a:schemeClr val="bg1"/>
                 </a:solidFill>
               </a:rPr>
-              <a:t>Covers it: "This warning is FAKE. Do NOT call."</a:t>
+              <a:t>It covers the page: "This warning is FAKE. Do NOT call."</a:t>
             </a:r>
             <a:endParaRPr lang="en-US" sz="1400" dirty="0"/>
           </a:p>
@@ -4335,7 +4335,7 @@
                   <a:schemeClr val="accent2"/>
                 </a:solidFill>
               </a:rPr>
-              <a:t>Sarah gets alert #1, silently</a:t>
+              <a:t>Sarah's phone gets a quiet alert</a:t>
             </a:r>
             <a:endParaRPr lang="en-US" sz="1400" dirty="0"/>
           </a:p>
@@ -4555,7 +4555,7 @@
                   <a:schemeClr val="bg1"/>
                 </a:solidFill>
               </a:rPr>
-              <a:t>AnyDesk? HoldOn says STOP</a:t>
+              <a:t>"Install this app." HoldOn: STOP</a:t>
             </a:r>
             <a:endParaRPr lang="en-US" sz="2800" dirty="0"/>
           </a:p>
@@ -4591,7 +4591,7 @@
                   <a:schemeClr val="accent3"/>
                 </a:solidFill>
               </a:rPr>
-              <a:t>THE DANGER MOMENT</a:t>
+              <a:t>MOST DANGEROUS STEP</a:t>
             </a:r>
             <a:endParaRPr lang="en-US" sz="1200" dirty="0"/>
           </a:p>
@@ -4631,7 +4631,7 @@
                   <a:schemeClr val="bg1"/>
                 </a:solidFill>
               </a:rPr>
-              <a:t>Scammer asks her to install AnyDesk to control her screen</a:t>
+              <a:t>The scammer tells her to get AnyDesk, an app that lets him control her computer</a:t>
             </a:r>
             <a:endParaRPr lang="en-US" sz="1400" dirty="0"/>
           </a:p>
@@ -4649,7 +4649,7 @@
                   <a:schemeClr val="bg1"/>
                 </a:solidFill>
               </a:rPr>
-              <a:t>HoldOn recognises the site instantly</a:t>
+              <a:t>HoldOn knows this app and steps in right away</a:t>
             </a:r>
             <a:endParaRPr lang="en-US" sz="1400" dirty="0"/>
           </a:p>
@@ -4667,7 +4667,7 @@
                   <a:schemeClr val="bg1"/>
                 </a:solidFill>
               </a:rPr>
-              <a:t>Huge, elder-friendly STOP warning</a:t>
+              <a:t>A giant STOP sign she can't miss</a:t>
             </a:r>
             <a:endParaRPr lang="en-US" sz="1400" dirty="0"/>
           </a:p>
@@ -4730,7 +4730,7 @@
                   <a:schemeClr val="accent2"/>
                 </a:solidFill>
               </a:rPr>
-              <a:t>"Sarah has been notified and will call you."</a:t>
+              <a:t>"Sarah knows. She will call you."</a:t>
             </a:r>
             <a:endParaRPr lang="en-US" sz="1400" dirty="0"/>
           </a:p>
@@ -4986,7 +4986,7 @@
                   <a:schemeClr val="accent3"/>
                 </a:solidFill>
               </a:rPr>
-              <a:t>SARAH'S PHONE</a:t>
+              <a:t>ON SARAH'S PHONE</a:t>
             </a:r>
             <a:endParaRPr lang="en-US" sz="1200" dirty="0"/>
           </a:p>
@@ -5026,7 +5026,7 @@
                   <a:schemeClr val="bg1"/>
                 </a:solidFill>
               </a:rPr>
-              <a:t>AI writes the alert from context: popup, then AnyDesk</a:t>
+              <a:t>AI explains what happened, in plain words</a:t>
             </a:r>
             <a:endParaRPr lang="en-US" sz="1400" dirty="0"/>
           </a:p>
@@ -5044,7 +5044,7 @@
                   <a:schemeClr val="bg1"/>
                 </a:solidFill>
               </a:rPr>
-              <a:t>Tells Sarah what to do when she calls</a:t>
+              <a:t>It tells Sarah exactly what to do</a:t>
             </a:r>
             <a:endParaRPr lang="en-US" sz="1400" dirty="0"/>
           </a:p>
@@ -5062,7 +5062,7 @@
                   <a:schemeClr val="bg1"/>
                 </a:solidFill>
               </a:rPr>
-              <a:t>On Telegram: a channel the scammer can't see</a:t>
+              <a:t>The scammer can't see this message</a:t>
             </a:r>
             <a:endParaRPr lang="en-US" sz="1400" dirty="0"/>
           </a:p>
@@ -5125,7 +5125,7 @@
                   <a:schemeClr val="accent1"/>
                 </a:solidFill>
               </a:rPr>
-              <a:t>Help arrives from outside the scam</a:t>
+              <a:t>Help comes from outside the scam</a:t>
             </a:r>
             <a:endParaRPr lang="en-US" sz="1400" dirty="0"/>
           </a:p>
@@ -5421,7 +5421,7 @@
                   <a:schemeClr val="bg1"/>
                 </a:solidFill>
               </a:rPr>
-              <a:t>Sarah calls Margaret and breaks the isolation</a:t>
+              <a:t>Sarah calls Mom and tells her to hang up</a:t>
             </a:r>
             <a:endParaRPr lang="en-US" sz="1400" dirty="0"/>
           </a:p>
@@ -5439,7 +5439,7 @@
                   <a:schemeClr val="bg1"/>
                 </a:solidFill>
               </a:rPr>
-              <a:t>Taps "It was a scam — I stopped it"</a:t>
+              <a:t>She taps "It was a scam — I stopped it"</a:t>
             </a:r>
             <a:endParaRPr lang="en-US" sz="1400" dirty="0"/>
           </a:p>
@@ -5457,7 +5457,7 @@
                   <a:schemeClr val="bg1"/>
                 </a:solidFill>
               </a:rPr>
-              <a:t>The alert updates: "Logged: scam stopped"</a:t>
+              <a:t>HoldOn saves the result: scam stopped</a:t>
             </a:r>
             <a:endParaRPr lang="en-US" sz="1400" dirty="0"/>
           </a:p>
@@ -5520,7 +5520,7 @@
                   <a:schemeClr val="accent1"/>
                 </a:solidFill>
               </a:rPr>
-              <a:t>Every alert measures its own impact</a:t>
+              <a:t>Every alert tells us if HoldOn helped</a:t>
             </a:r>
             <a:endParaRPr lang="en-US" sz="1400" dirty="0"/>
           </a:p>
@@ -5740,7 +5740,7 @@
                   <a:schemeClr val="bg1"/>
                 </a:solidFill>
               </a:rPr>
-              <a:t>Impact, measured from day one</a:t>
+              <a:t>We count every save</a:t>
             </a:r>
             <a:endParaRPr lang="en-US" sz="2800" dirty="0"/>
           </a:p>
@@ -5776,7 +5776,7 @@
                   <a:schemeClr val="accent3"/>
                 </a:solidFill>
               </a:rPr>
-              <a:t>ANSWERED IN TELEGRAM</a:t>
+              <a:t>SARAH'S ANSWERS</a:t>
             </a:r>
             <a:endParaRPr lang="en-US" sz="1100" dirty="0"/>
           </a:p>
@@ -5863,7 +5863,7 @@
                   <a:schemeClr val="accent3"/>
                 </a:solidFill>
               </a:rPr>
-              <a:t>ROLLED UP ON SARAH'S DASHBOARD</a:t>
+              <a:t>THE SCOREBOARD</a:t>
             </a:r>
             <a:endParaRPr lang="en-US" sz="1100" dirty="0"/>
           </a:p>
@@ -5954,7 +5954,25 @@
                   <a:schemeClr val="bg1"/>
                 </a:solidFill>
               </a:rPr>
-              <a:t>Scams stopped, false alarms and precision, counted live</a:t>
+              <a:t>Counts scams stopped and false alarms (alerts that weren't real scams)</a:t>
+            </a:r>
+            <a:endParaRPr lang="en-US" sz="1400" dirty="0"/>
+          </a:p>
+          <a:p>
+            <a:pPr marL="190500" indent="-190500">
+              <a:spcAft>
+                <a:spcPts val="600"/>
+              </a:spcAft>
+              <a:buSzPct val="100000"/>
+              <a:buChar char="•"/>
+            </a:pPr>
+            <a:r>
+              <a:rPr lang="en-US" sz="1400" dirty="0">
+                <a:solidFill>
+                  <a:schemeClr val="bg1"/>
+                </a:solidFill>
+              </a:rPr>
+              <a:t>Precision = how often an alert was a real scam</a:t>
             </a:r>
             <a:endParaRPr lang="en-US" sz="1400" dirty="0"/>
           </a:p>
@@ -5969,7 +5987,7 @@
                   <a:schemeClr val="bg1"/>
                 </a:solidFill>
               </a:rPr>
-              <a:t>Real counts from our test runs today: false alarms were triggered on purpose to tune detection</a:t>
+              <a:t>Real numbers from our tests today. Some false alarms were on purpose</a:t>
             </a:r>
             <a:endParaRPr lang="en-US" sz="1400" dirty="0"/>
           </a:p>
@@ -6138,7 +6156,7 @@
                   <a:schemeClr val="bg1"/>
                 </a:solidFill>
               </a:rPr>
-              <a:t>Scammer: "Remove HoldOn"</a:t>
+              <a:t>Scammer: "Delete HoldOn"</a:t>
             </a:r>
             <a:endParaRPr lang="en-US" sz="2800" dirty="0"/>
           </a:p>
@@ -6174,7 +6192,7 @@
                   <a:schemeClr val="accent3"/>
                 </a:solidFill>
               </a:rPr>
-              <a:t>TAMPER-PROOF</a:t>
+              <a:t>CAN'T BE SECRETLY REMOVED</a:t>
             </a:r>
             <a:endParaRPr lang="en-US" sz="1200" dirty="0"/>
           </a:p>
@@ -6214,7 +6232,7 @@
                   <a:schemeClr val="bg1"/>
                 </a:solidFill>
               </a:rPr>
-              <a:t>Scammers often make victims remove protection</a:t>
+              <a:t>Scammers often tell people to delete safety apps</a:t>
             </a:r>
             <a:endParaRPr lang="en-US" sz="1400" dirty="0"/>
           </a:p>
@@ -6232,7 +6250,7 @@
                   <a:schemeClr val="bg1"/>
                 </a:solidFill>
               </a:rPr>
-              <a:t>Removing HoldOn triggers one last alert</a:t>
+              <a:t>If HoldOn is removed, it sends one last alert</a:t>
             </a:r>
             <a:endParaRPr lang="en-US" sz="1400" dirty="0"/>
           </a:p>
@@ -6250,7 +6268,7 @@
                   <a:schemeClr val="bg1"/>
                 </a:solidFill>
               </a:rPr>
-              <a:t>Family knows, even after it's gone</a:t>
+              <a:t>So Sarah still finds out</a:t>
             </a:r>
             <a:endParaRPr lang="en-US" sz="1400" dirty="0"/>
           </a:p>
@@ -6313,7 +6331,7 @@
                   <a:schemeClr val="accent3"/>
                 </a:solidFill>
               </a:rPr>
-              <a:t>Removing HoldOn alerts Sarah too</a:t>
+              <a:t>Deleting HoldOn alerts Sarah too</a:t>
             </a:r>
             <a:endParaRPr lang="en-US" sz="1400" dirty="0"/>
           </a:p>
@@ -6412,7 +6430,7 @@
                   <a:schemeClr val="bg2"/>
                 </a:solidFill>
               </a:rPr>
-              <a:t>Exact alert text sent to Sarah's Telegram</a:t>
+              <a:t>The real message Sarah gets on her phone</a:t>
             </a:r>
             <a:endParaRPr lang="en-US" sz="1200" dirty="0"/>
           </a:p>

</xml_diff>